<commit_message>
last update (typo correction)
</commit_message>
<xml_diff>
--- a/NLP/presentation/Cours_TALN_Supaero_2020.pptx
+++ b/NLP/presentation/Cours_TALN_Supaero_2020.pptx
@@ -5,7 +5,7 @@
     <p:sldMasterId id="2147483678" r:id="rId1"/>
   </p:sldMasterIdLst>
   <p:notesMasterIdLst>
-    <p:notesMasterId r:id="rId41"/>
+    <p:notesMasterId r:id="rId43"/>
   </p:notesMasterIdLst>
   <p:sldIdLst>
     <p:sldId id="256" r:id="rId2"/>
@@ -45,8 +45,10 @@
     <p:sldId id="301" r:id="rId36"/>
     <p:sldId id="302" r:id="rId37"/>
     <p:sldId id="303" r:id="rId38"/>
-    <p:sldId id="295" r:id="rId39"/>
-    <p:sldId id="296" r:id="rId40"/>
+    <p:sldId id="304" r:id="rId39"/>
+    <p:sldId id="305" r:id="rId40"/>
+    <p:sldId id="295" r:id="rId41"/>
+    <p:sldId id="296" r:id="rId42"/>
   </p:sldIdLst>
   <p:sldSz cx="12192000" cy="6858000"/>
   <p:notesSz cx="6858000" cy="9144000"/>
@@ -235,7 +237,7 @@
           <a:p>
             <a:fld id="{216B142A-7A08-4AB5-B44E-770F0790EB00}" type="datetimeFigureOut">
               <a:rPr lang="fr-FR" smtClean="0"/>
-              <a:t>30/11/2020</a:t>
+              <a:t>08/12/2020</a:t>
             </a:fld>
             <a:endParaRPr lang="fr-FR"/>
           </a:p>
@@ -973,7 +975,7 @@
           <a:p>
             <a:fld id="{711406F1-75DF-4457-98AF-F963FD2593C4}" type="datetimeFigureOut">
               <a:rPr lang="fr-FR" smtClean="0"/>
-              <a:t>30/11/2020</a:t>
+              <a:t>08/12/2020</a:t>
             </a:fld>
             <a:endParaRPr lang="fr-FR"/>
           </a:p>
@@ -1181,7 +1183,7 @@
           <a:p>
             <a:fld id="{711406F1-75DF-4457-98AF-F963FD2593C4}" type="datetimeFigureOut">
               <a:rPr lang="fr-FR" smtClean="0"/>
-              <a:t>30/11/2020</a:t>
+              <a:t>08/12/2020</a:t>
             </a:fld>
             <a:endParaRPr lang="fr-FR"/>
           </a:p>
@@ -1437,7 +1439,7 @@
           <a:p>
             <a:fld id="{711406F1-75DF-4457-98AF-F963FD2593C4}" type="datetimeFigureOut">
               <a:rPr lang="fr-FR" smtClean="0"/>
-              <a:t>30/11/2020</a:t>
+              <a:t>08/12/2020</a:t>
             </a:fld>
             <a:endParaRPr lang="fr-FR"/>
           </a:p>
@@ -2428,7 +2430,7 @@
           <a:p>
             <a:fld id="{711406F1-75DF-4457-98AF-F963FD2593C4}" type="datetimeFigureOut">
               <a:rPr lang="fr-FR" smtClean="0"/>
-              <a:t>30/11/2020</a:t>
+              <a:t>08/12/2020</a:t>
             </a:fld>
             <a:endParaRPr lang="fr-FR"/>
           </a:p>
@@ -2778,7 +2780,7 @@
           <a:p>
             <a:fld id="{711406F1-75DF-4457-98AF-F963FD2593C4}" type="datetimeFigureOut">
               <a:rPr lang="fr-FR" smtClean="0"/>
-              <a:t>30/11/2020</a:t>
+              <a:t>08/12/2020</a:t>
             </a:fld>
             <a:endParaRPr lang="fr-FR"/>
           </a:p>
@@ -3060,7 +3062,7 @@
           <a:p>
             <a:fld id="{711406F1-75DF-4457-98AF-F963FD2593C4}" type="datetimeFigureOut">
               <a:rPr lang="fr-FR" smtClean="0"/>
-              <a:t>30/11/2020</a:t>
+              <a:t>08/12/2020</a:t>
             </a:fld>
             <a:endParaRPr lang="fr-FR"/>
           </a:p>
@@ -3439,7 +3441,7 @@
           <a:p>
             <a:fld id="{711406F1-75DF-4457-98AF-F963FD2593C4}" type="datetimeFigureOut">
               <a:rPr lang="fr-FR" smtClean="0"/>
-              <a:t>30/11/2020</a:t>
+              <a:t>08/12/2020</a:t>
             </a:fld>
             <a:endParaRPr lang="fr-FR"/>
           </a:p>
@@ -3557,7 +3559,7 @@
           <a:p>
             <a:fld id="{711406F1-75DF-4457-98AF-F963FD2593C4}" type="datetimeFigureOut">
               <a:rPr lang="fr-FR" smtClean="0"/>
-              <a:t>30/11/2020</a:t>
+              <a:t>08/12/2020</a:t>
             </a:fld>
             <a:endParaRPr lang="fr-FR"/>
           </a:p>
@@ -3728,7 +3730,7 @@
           <a:p>
             <a:fld id="{711406F1-75DF-4457-98AF-F963FD2593C4}" type="datetimeFigureOut">
               <a:rPr lang="fr-FR" smtClean="0"/>
-              <a:t>30/11/2020</a:t>
+              <a:t>08/12/2020</a:t>
             </a:fld>
             <a:endParaRPr lang="fr-FR"/>
           </a:p>
@@ -4082,7 +4084,7 @@
           <a:p>
             <a:fld id="{711406F1-75DF-4457-98AF-F963FD2593C4}" type="datetimeFigureOut">
               <a:rPr lang="fr-FR" smtClean="0"/>
-              <a:t>30/11/2020</a:t>
+              <a:t>08/12/2020</a:t>
             </a:fld>
             <a:endParaRPr lang="fr-FR"/>
           </a:p>
@@ -4471,7 +4473,7 @@
           <a:p>
             <a:fld id="{711406F1-75DF-4457-98AF-F963FD2593C4}" type="datetimeFigureOut">
               <a:rPr lang="fr-FR" smtClean="0"/>
-              <a:t>30/11/2020</a:t>
+              <a:t>08/12/2020</a:t>
             </a:fld>
             <a:endParaRPr lang="fr-FR"/>
           </a:p>
@@ -4765,7 +4767,7 @@
           <a:p>
             <a:fld id="{711406F1-75DF-4457-98AF-F963FD2593C4}" type="datetimeFigureOut">
               <a:rPr lang="fr-FR" smtClean="0"/>
-              <a:t>30/11/2020</a:t>
+              <a:t>08/12/2020</a:t>
             </a:fld>
             <a:endParaRPr lang="fr-FR"/>
           </a:p>
@@ -5379,7 +5381,6 @@
               <a:rPr lang="fr-FR" sz="3800" dirty="0" smtClean="0"/>
               <a:t>2020-2021</a:t>
             </a:r>
-            <a:endParaRPr lang="fr-FR" sz="3800" dirty="0" smtClean="0"/>
           </a:p>
           <a:p>
             <a:endParaRPr lang="fr-FR" sz="3800" dirty="0"/>
@@ -20518,13 +20519,8 @@
             </a:pPr>
             <a:r>
               <a:rPr lang="fr-FR" dirty="0" smtClean="0"/>
-              <a:t>Un module de Self Attention peut ne pas </a:t>
-            </a:r>
-            <a:r>
-              <a:rPr lang="fr-FR" dirty="0" smtClean="0"/>
-              <a:t>couvrir tous les cas d’usage</a:t>
-            </a:r>
-            <a:endParaRPr lang="fr-FR" dirty="0" smtClean="0"/>
+              <a:t>Un module de Self Attention peut ne pas couvrir tous les cas d’usage</a:t>
+            </a:r>
           </a:p>
           <a:p>
             <a:pPr marL="742950" lvl="1" indent="-285750">
@@ -20879,20 +20875,8 @@
           <a:lstStyle/>
           <a:p>
             <a:r>
-              <a:rPr lang="fr-FR" dirty="0" err="1" smtClean="0"/>
-              <a:t>CamemBERT</a:t>
-            </a:r>
-            <a:r>
               <a:rPr lang="fr-FR" dirty="0" smtClean="0"/>
-              <a:t> (10 </a:t>
-            </a:r>
-            <a:r>
-              <a:rPr lang="fr-FR" dirty="0" err="1" smtClean="0"/>
-              <a:t>nov</a:t>
-            </a:r>
-            <a:r>
-              <a:rPr lang="fr-FR" dirty="0" smtClean="0"/>
-              <a:t> 2019)</a:t>
+              <a:t>Des modèles toujours plus complexes…</a:t>
             </a:r>
             <a:endParaRPr lang="fr-FR" dirty="0"/>
           </a:p>
@@ -20921,8 +20905,8 @@
         </p:blipFill>
         <p:spPr bwMode="auto">
           <a:xfrm>
-            <a:off x="2316480" y="1757083"/>
-            <a:ext cx="7620000" cy="3810000"/>
+            <a:off x="1184204" y="1357455"/>
+            <a:ext cx="3926276" cy="1963138"/>
           </a:xfrm>
           <a:prstGeom prst="rect">
             <a:avLst/>
@@ -20939,6 +20923,173 @@
           </a:extLst>
         </p:spPr>
       </p:pic>
+      <p:sp>
+        <p:nvSpPr>
+          <p:cNvPr id="3" name="ZoneTexte 2"/>
+          <p:cNvSpPr txBox="1"/>
+          <p:nvPr/>
+        </p:nvSpPr>
+        <p:spPr>
+          <a:xfrm>
+            <a:off x="6398542" y="2154358"/>
+            <a:ext cx="5793458" cy="369332"/>
+          </a:xfrm>
+          <a:prstGeom prst="rect">
+            <a:avLst/>
+          </a:prstGeom>
+          <a:noFill/>
+        </p:spPr>
+        <p:txBody>
+          <a:bodyPr wrap="square" rtlCol="0">
+            <a:spAutoFit/>
+          </a:bodyPr>
+          <a:lstStyle/>
+          <a:p>
+            <a:r>
+              <a:rPr lang="fr-FR" dirty="0" smtClean="0"/>
+              <a:t>124 millions de paramètres au minimum </a:t>
+            </a:r>
+            <a:endParaRPr lang="fr-FR" dirty="0"/>
+          </a:p>
+        </p:txBody>
+      </p:sp>
+      <p:pic>
+        <p:nvPicPr>
+          <p:cNvPr id="1026" name="Picture 2" descr="GPT-3 : OpenAI dévoile son impressionnant modèle de traitement de langage  naturel"/>
+          <p:cNvPicPr>
+            <a:picLocks noChangeAspect="1" noChangeArrowheads="1"/>
+          </p:cNvPicPr>
+          <p:nvPr/>
+        </p:nvPicPr>
+        <p:blipFill rotWithShape="1">
+          <a:blip r:embed="rId3" cstate="print">
+            <a:extLst>
+              <a:ext uri="{28A0092B-C50C-407E-A947-70E740481C1C}">
+                <a14:useLocalDpi xmlns:a14="http://schemas.microsoft.com/office/drawing/2010/main" val="0"/>
+              </a:ext>
+            </a:extLst>
+          </a:blip>
+          <a:srcRect l="33016" t="25617" r="34065" b="28200"/>
+          <a:stretch/>
+        </p:blipFill>
+        <p:spPr bwMode="auto">
+          <a:xfrm>
+            <a:off x="1387405" y="3539962"/>
+            <a:ext cx="1457396" cy="1382787"/>
+          </a:xfrm>
+          <a:prstGeom prst="rect">
+            <a:avLst/>
+          </a:prstGeom>
+          <a:noFill/>
+          <a:extLst>
+            <a:ext uri="{909E8E84-426E-40DD-AFC4-6F175D3DCCD1}">
+              <a14:hiddenFill xmlns:a14="http://schemas.microsoft.com/office/drawing/2010/main">
+                <a:solidFill>
+                  <a:srgbClr val="FFFFFF"/>
+                </a:solidFill>
+              </a14:hiddenFill>
+            </a:ext>
+          </a:extLst>
+        </p:spPr>
+      </p:pic>
+      <p:sp>
+        <p:nvSpPr>
+          <p:cNvPr id="4" name="ZoneTexte 3"/>
+          <p:cNvSpPr txBox="1"/>
+          <p:nvPr/>
+        </p:nvSpPr>
+        <p:spPr>
+          <a:xfrm>
+            <a:off x="4865511" y="2079377"/>
+            <a:ext cx="1454009" cy="369332"/>
+          </a:xfrm>
+          <a:prstGeom prst="rect">
+            <a:avLst/>
+          </a:prstGeom>
+          <a:noFill/>
+        </p:spPr>
+        <p:txBody>
+          <a:bodyPr wrap="square" rtlCol="0">
+            <a:spAutoFit/>
+          </a:bodyPr>
+          <a:lstStyle/>
+          <a:p>
+            <a:r>
+              <a:rPr lang="fr-FR" dirty="0" smtClean="0"/>
+              <a:t>(</a:t>
+            </a:r>
+            <a:r>
+              <a:rPr lang="fr-FR" dirty="0" err="1" smtClean="0"/>
+              <a:t>nov</a:t>
+            </a:r>
+            <a:r>
+              <a:rPr lang="fr-FR" dirty="0" smtClean="0"/>
+              <a:t> 2019)</a:t>
+            </a:r>
+            <a:endParaRPr lang="fr-FR" dirty="0"/>
+          </a:p>
+        </p:txBody>
+      </p:sp>
+      <p:sp>
+        <p:nvSpPr>
+          <p:cNvPr id="7" name="ZoneTexte 6"/>
+          <p:cNvSpPr txBox="1"/>
+          <p:nvPr/>
+        </p:nvSpPr>
+        <p:spPr>
+          <a:xfrm>
+            <a:off x="3059290" y="4077218"/>
+            <a:ext cx="3260230" cy="369332"/>
+          </a:xfrm>
+          <a:prstGeom prst="rect">
+            <a:avLst/>
+          </a:prstGeom>
+          <a:noFill/>
+        </p:spPr>
+        <p:txBody>
+          <a:bodyPr wrap="square" rtlCol="0">
+            <a:spAutoFit/>
+          </a:bodyPr>
+          <a:lstStyle/>
+          <a:p>
+            <a:r>
+              <a:rPr lang="fr-FR" dirty="0" smtClean="0"/>
+              <a:t>GPT-3 (mai 2020)</a:t>
+            </a:r>
+            <a:endParaRPr lang="fr-FR" dirty="0"/>
+          </a:p>
+        </p:txBody>
+      </p:sp>
+      <p:sp>
+        <p:nvSpPr>
+          <p:cNvPr id="8" name="ZoneTexte 7"/>
+          <p:cNvSpPr txBox="1"/>
+          <p:nvPr/>
+        </p:nvSpPr>
+        <p:spPr>
+          <a:xfrm>
+            <a:off x="6398542" y="4046689"/>
+            <a:ext cx="5793458" cy="369332"/>
+          </a:xfrm>
+          <a:prstGeom prst="rect">
+            <a:avLst/>
+          </a:prstGeom>
+          <a:noFill/>
+        </p:spPr>
+        <p:txBody>
+          <a:bodyPr wrap="square" rtlCol="0">
+            <a:spAutoFit/>
+          </a:bodyPr>
+          <a:lstStyle/>
+          <a:p>
+            <a:r>
+              <a:rPr lang="fr-FR" dirty="0" smtClean="0"/>
+              <a:t>175 milliards de paramètres </a:t>
+            </a:r>
+            <a:endParaRPr lang="fr-FR" dirty="0"/>
+          </a:p>
+        </p:txBody>
+      </p:sp>
     </p:spTree>
     <p:extLst>
       <p:ext uri="{BB962C8B-B14F-4D97-AF65-F5344CB8AC3E}">
@@ -20983,7 +21134,7 @@
             <a:spLocks noGrp="1"/>
           </p:cNvSpPr>
           <p:nvPr>
-            <p:ph type="ctrTitle"/>
+            <p:ph type="title"/>
           </p:nvPr>
         </p:nvSpPr>
         <p:spPr/>
@@ -20993,35 +21144,230 @@
           <a:p>
             <a:r>
               <a:rPr lang="fr-FR" dirty="0" smtClean="0"/>
-              <a:t>Quelques ressources</a:t>
+              <a:t>…mais de moins en moins contrôlés</a:t>
             </a:r>
             <a:endParaRPr lang="fr-FR" dirty="0"/>
           </a:p>
         </p:txBody>
       </p:sp>
-      <p:sp>
-        <p:nvSpPr>
-          <p:cNvPr id="3" name="Sous-titre 2"/>
-          <p:cNvSpPr>
-            <a:spLocks noGrp="1"/>
-          </p:cNvSpPr>
-          <p:nvPr>
-            <p:ph type="subTitle" idx="1"/>
-          </p:nvPr>
-        </p:nvSpPr>
-        <p:spPr/>
-        <p:txBody>
-          <a:bodyPr/>
+      <p:pic>
+        <p:nvPicPr>
+          <p:cNvPr id="5" name="Image 4"/>
+          <p:cNvPicPr>
+            <a:picLocks noChangeAspect="1"/>
+          </p:cNvPicPr>
+          <p:nvPr/>
+        </p:nvPicPr>
+        <p:blipFill rotWithShape="1">
+          <a:blip r:embed="rId2"/>
+          <a:srcRect l="12158" t="20922" r="67119" b="16257"/>
+          <a:stretch/>
+        </p:blipFill>
+        <p:spPr>
+          <a:xfrm>
+            <a:off x="593869" y="1535721"/>
+            <a:ext cx="2207946" cy="3763107"/>
+          </a:xfrm>
+          <a:prstGeom prst="rect">
+            <a:avLst/>
+          </a:prstGeom>
+        </p:spPr>
+      </p:pic>
+      <p:sp>
+        <p:nvSpPr>
+          <p:cNvPr id="6" name="Rectangle 5"/>
+          <p:cNvSpPr/>
+          <p:nvPr/>
+        </p:nvSpPr>
+        <p:spPr>
+          <a:xfrm>
+            <a:off x="190908" y="6386119"/>
+            <a:ext cx="5221814" cy="369332"/>
+          </a:xfrm>
+          <a:prstGeom prst="rect">
+            <a:avLst/>
+          </a:prstGeom>
+        </p:spPr>
+        <p:txBody>
+          <a:bodyPr wrap="none">
+            <a:spAutoFit/>
+          </a:bodyPr>
           <a:lstStyle/>
           <a:p>
-            <a:endParaRPr lang="fr-FR"/>
-          </a:p>
-        </p:txBody>
-      </p:sp>
+            <a:r>
+              <a:rPr lang="fr-FR" dirty="0"/>
+              <a:t>https://blog.rasa.com/gpt-3-careful-first-impressions/</a:t>
+            </a:r>
+          </a:p>
+        </p:txBody>
+      </p:sp>
+      <p:pic>
+        <p:nvPicPr>
+          <p:cNvPr id="9" name="Image 8"/>
+          <p:cNvPicPr>
+            <a:picLocks noChangeAspect="1"/>
+          </p:cNvPicPr>
+          <p:nvPr/>
+        </p:nvPicPr>
+        <p:blipFill rotWithShape="1">
+          <a:blip r:embed="rId3"/>
+          <a:srcRect l="11887" t="28205" r="41801" b="29887"/>
+          <a:stretch/>
+        </p:blipFill>
+        <p:spPr>
+          <a:xfrm>
+            <a:off x="2846798" y="2082131"/>
+            <a:ext cx="4927510" cy="2506895"/>
+          </a:xfrm>
+          <a:prstGeom prst="rect">
+            <a:avLst/>
+          </a:prstGeom>
+        </p:spPr>
+      </p:pic>
+      <p:pic>
+        <p:nvPicPr>
+          <p:cNvPr id="10" name="Image 9"/>
+          <p:cNvPicPr>
+            <a:picLocks noChangeAspect="1"/>
+          </p:cNvPicPr>
+          <p:nvPr/>
+        </p:nvPicPr>
+        <p:blipFill rotWithShape="1">
+          <a:blip r:embed="rId4"/>
+          <a:srcRect l="12337" t="23157" r="42072" b="19871"/>
+          <a:stretch/>
+        </p:blipFill>
+        <p:spPr>
+          <a:xfrm>
+            <a:off x="7819291" y="1870863"/>
+            <a:ext cx="4124616" cy="2897825"/>
+          </a:xfrm>
+          <a:prstGeom prst="rect">
+            <a:avLst/>
+          </a:prstGeom>
+        </p:spPr>
+      </p:pic>
+      <p:pic>
+        <p:nvPicPr>
+          <p:cNvPr id="2050" name="Picture 2" descr="ICAEW highlights the need for checks on SEISS | Bates Weston"/>
+          <p:cNvPicPr>
+            <a:picLocks noChangeAspect="1" noChangeArrowheads="1"/>
+          </p:cNvPicPr>
+          <p:nvPr/>
+        </p:nvPicPr>
+        <p:blipFill rotWithShape="1">
+          <a:blip r:embed="rId5" cstate="print">
+            <a:extLst>
+              <a:ext uri="{28A0092B-C50C-407E-A947-70E740481C1C}">
+                <a14:useLocalDpi xmlns:a14="http://schemas.microsoft.com/office/drawing/2010/main" val="0"/>
+              </a:ext>
+            </a:extLst>
+          </a:blip>
+          <a:srcRect t="11201" r="47558" b="11592"/>
+          <a:stretch/>
+        </p:blipFill>
+        <p:spPr bwMode="auto">
+          <a:xfrm>
+            <a:off x="6613285" y="4768688"/>
+            <a:ext cx="921179" cy="903112"/>
+          </a:xfrm>
+          <a:prstGeom prst="rect">
+            <a:avLst/>
+          </a:prstGeom>
+          <a:noFill/>
+          <a:extLst>
+            <a:ext uri="{909E8E84-426E-40DD-AFC4-6F175D3DCCD1}">
+              <a14:hiddenFill xmlns:a14="http://schemas.microsoft.com/office/drawing/2010/main">
+                <a:solidFill>
+                  <a:srgbClr val="FFFFFF"/>
+                </a:solidFill>
+              </a14:hiddenFill>
+            </a:ext>
+          </a:extLst>
+        </p:spPr>
+      </p:pic>
+      <p:pic>
+        <p:nvPicPr>
+          <p:cNvPr id="14" name="Picture 2" descr="ICAEW highlights the need for checks on SEISS | Bates Weston"/>
+          <p:cNvPicPr>
+            <a:picLocks noChangeAspect="1" noChangeArrowheads="1"/>
+          </p:cNvPicPr>
+          <p:nvPr/>
+        </p:nvPicPr>
+        <p:blipFill rotWithShape="1">
+          <a:blip r:embed="rId5" cstate="print">
+            <a:extLst>
+              <a:ext uri="{28A0092B-C50C-407E-A947-70E740481C1C}">
+                <a14:useLocalDpi xmlns:a14="http://schemas.microsoft.com/office/drawing/2010/main" val="0"/>
+              </a:ext>
+            </a:extLst>
+          </a:blip>
+          <a:srcRect l="51607"/>
+          <a:stretch/>
+        </p:blipFill>
+        <p:spPr bwMode="auto">
+          <a:xfrm>
+            <a:off x="10730650" y="4916611"/>
+            <a:ext cx="850060" cy="1169708"/>
+          </a:xfrm>
+          <a:prstGeom prst="rect">
+            <a:avLst/>
+          </a:prstGeom>
+          <a:noFill/>
+          <a:extLst>
+            <a:ext uri="{909E8E84-426E-40DD-AFC4-6F175D3DCCD1}">
+              <a14:hiddenFill xmlns:a14="http://schemas.microsoft.com/office/drawing/2010/main">
+                <a:solidFill>
+                  <a:srgbClr val="FFFFFF"/>
+                </a:solidFill>
+              </a14:hiddenFill>
+            </a:ext>
+          </a:extLst>
+        </p:spPr>
+      </p:pic>
+      <p:pic>
+        <p:nvPicPr>
+          <p:cNvPr id="16" name="Picture 2" descr="ICAEW highlights the need for checks on SEISS | Bates Weston"/>
+          <p:cNvPicPr>
+            <a:picLocks noChangeAspect="1" noChangeArrowheads="1"/>
+          </p:cNvPicPr>
+          <p:nvPr/>
+        </p:nvPicPr>
+        <p:blipFill rotWithShape="1">
+          <a:blip r:embed="rId5" cstate="print">
+            <a:extLst>
+              <a:ext uri="{28A0092B-C50C-407E-A947-70E740481C1C}">
+                <a14:useLocalDpi xmlns:a14="http://schemas.microsoft.com/office/drawing/2010/main" val="0"/>
+              </a:ext>
+            </a:extLst>
+          </a:blip>
+          <a:srcRect t="11201" r="47558" b="11592"/>
+          <a:stretch/>
+        </p:blipFill>
+        <p:spPr bwMode="auto">
+          <a:xfrm>
+            <a:off x="1745252" y="5390917"/>
+            <a:ext cx="921179" cy="903112"/>
+          </a:xfrm>
+          <a:prstGeom prst="rect">
+            <a:avLst/>
+          </a:prstGeom>
+          <a:noFill/>
+          <a:extLst>
+            <a:ext uri="{909E8E84-426E-40DD-AFC4-6F175D3DCCD1}">
+              <a14:hiddenFill xmlns:a14="http://schemas.microsoft.com/office/drawing/2010/main">
+                <a:solidFill>
+                  <a:srgbClr val="FFFFFF"/>
+                </a:solidFill>
+              </a14:hiddenFill>
+            </a:ext>
+          </a:extLst>
+        </p:spPr>
+      </p:pic>
     </p:spTree>
     <p:extLst>
       <p:ext uri="{BB962C8B-B14F-4D97-AF65-F5344CB8AC3E}">
-        <p14:creationId xmlns:p14="http://schemas.microsoft.com/office/powerpoint/2010/main" val="1929882029"/>
+        <p14:creationId xmlns:p14="http://schemas.microsoft.com/office/powerpoint/2010/main" val="457545641"/>
       </p:ext>
     </p:extLst>
   </p:cSld>
@@ -21072,7 +21418,7 @@
           <a:p>
             <a:r>
               <a:rPr lang="fr-FR" dirty="0" smtClean="0"/>
-              <a:t>Ressources open source pour le NLP</a:t>
+              <a:t>Les défis du TAL</a:t>
             </a:r>
             <a:endParaRPr lang="fr-FR" dirty="0"/>
           </a:p>
@@ -21080,157 +21426,74 @@
       </p:sp>
       <p:sp>
         <p:nvSpPr>
-          <p:cNvPr id="3" name="Espace réservé du contenu 2"/>
-          <p:cNvSpPr>
-            <a:spLocks noGrp="1"/>
-          </p:cNvSpPr>
-          <p:nvPr>
-            <p:ph idx="1"/>
-          </p:nvPr>
-        </p:nvSpPr>
-        <p:spPr/>
-        <p:txBody>
-          <a:bodyPr/>
+          <p:cNvPr id="3" name="ZoneTexte 2"/>
+          <p:cNvSpPr txBox="1"/>
+          <p:nvPr/>
+        </p:nvSpPr>
+        <p:spPr>
+          <a:xfrm>
+            <a:off x="645724" y="2743200"/>
+            <a:ext cx="10961511" cy="1477328"/>
+          </a:xfrm>
+          <a:prstGeom prst="rect">
+            <a:avLst/>
+          </a:prstGeom>
+          <a:noFill/>
+        </p:spPr>
+        <p:txBody>
+          <a:bodyPr wrap="square" rtlCol="0">
+            <a:spAutoFit/>
+          </a:bodyPr>
           <a:lstStyle/>
           <a:p>
-            <a:pPr marL="0" indent="0">
-              <a:buNone/>
+            <a:pPr marL="285750" indent="-285750">
+              <a:buFont typeface="Arial" panose="020B0604020202020204" pitchFamily="34" charset="0"/>
+              <a:buChar char="•"/>
             </a:pPr>
             <a:r>
+              <a:rPr lang="fr-FR" dirty="0" smtClean="0"/>
+              <a:t>Les modèles actuels, entraînés de manière non supervisée sur des volumes considérables de données, </a:t>
+            </a:r>
+            <a:r>
               <a:rPr lang="fr-FR" b="1" dirty="0" smtClean="0"/>
-              <a:t>NLC / NER :</a:t>
-            </a:r>
-          </a:p>
-          <a:p>
-            <a:pPr>
-              <a:buFont typeface="Wingdings" panose="05000000000000000000" pitchFamily="2" charset="2"/>
-              <a:buChar char="§"/>
+              <a:t>fournissent une représentation de plus en plus fidèle du langage</a:t>
+            </a:r>
+            <a:r>
+              <a:rPr lang="fr-FR" dirty="0" smtClean="0"/>
+              <a:t>.</a:t>
+            </a:r>
+          </a:p>
+          <a:p>
+            <a:pPr marL="285750" indent="-285750">
+              <a:buFont typeface="Arial" panose="020B0604020202020204" pitchFamily="34" charset="0"/>
+              <a:buChar char="•"/>
             </a:pPr>
-            <a:r>
-              <a:rPr lang="fr-FR" dirty="0"/>
-              <a:t> </a:t>
+            <a:endParaRPr lang="fr-FR" dirty="0"/>
+          </a:p>
+          <a:p>
+            <a:pPr marL="285750" indent="-285750">
+              <a:buFont typeface="Arial" panose="020B0604020202020204" pitchFamily="34" charset="0"/>
+              <a:buChar char="•"/>
+            </a:pPr>
+            <a:r>
+              <a:rPr lang="fr-FR" b="1" dirty="0" smtClean="0"/>
+              <a:t>Le défi principal reste d’utiliser ces représentations dans un contexte supervisé </a:t>
+            </a:r>
+            <a:r>
+              <a:rPr lang="fr-FR" dirty="0" smtClean="0"/>
+              <a:t>pour mener un raisonnement (</a:t>
             </a:r>
             <a:r>
               <a:rPr lang="fr-FR" dirty="0" err="1" smtClean="0"/>
-              <a:t>spacy</a:t>
+              <a:t>e.g</a:t>
             </a:r>
             <a:r>
               <a:rPr lang="fr-FR" dirty="0" smtClean="0"/>
-              <a:t> : </a:t>
-            </a:r>
-            <a:r>
-              <a:rPr lang="fr-FR" dirty="0" err="1" smtClean="0"/>
-              <a:t>industrial</a:t>
-            </a:r>
-            <a:r>
-              <a:rPr lang="fr-FR" dirty="0" smtClean="0"/>
-              <a:t> </a:t>
-            </a:r>
-            <a:r>
-              <a:rPr lang="fr-FR" dirty="0" err="1" smtClean="0"/>
-              <a:t>strength</a:t>
-            </a:r>
-            <a:r>
-              <a:rPr lang="fr-FR" dirty="0" smtClean="0"/>
-              <a:t> </a:t>
-            </a:r>
-            <a:r>
-              <a:rPr lang="fr-FR" dirty="0" err="1" smtClean="0"/>
-              <a:t>nlp</a:t>
-            </a:r>
-            <a:endParaRPr lang="fr-FR" dirty="0" smtClean="0"/>
-          </a:p>
-          <a:p>
-            <a:pPr>
-              <a:buFont typeface="Wingdings" panose="05000000000000000000" pitchFamily="2" charset="2"/>
-              <a:buChar char="§"/>
-            </a:pPr>
-            <a:r>
-              <a:rPr lang="fr-FR" dirty="0"/>
-              <a:t> </a:t>
-            </a:r>
-            <a:r>
-              <a:rPr lang="fr-FR" dirty="0" smtClean="0"/>
-              <a:t>rasa </a:t>
-            </a:r>
-            <a:r>
-              <a:rPr lang="fr-FR" dirty="0" err="1" smtClean="0"/>
-              <a:t>nlu</a:t>
-            </a:r>
-            <a:endParaRPr lang="fr-FR" dirty="0" smtClean="0"/>
-          </a:p>
-          <a:p>
-            <a:pPr>
-              <a:buFont typeface="Wingdings" panose="05000000000000000000" pitchFamily="2" charset="2"/>
-              <a:buChar char="§"/>
-            </a:pPr>
-            <a:endParaRPr lang="fr-FR" dirty="0" smtClean="0"/>
-          </a:p>
-          <a:p>
-            <a:pPr marL="0" indent="0">
-              <a:buNone/>
-            </a:pPr>
-            <a:r>
-              <a:rPr lang="fr-FR" b="1" dirty="0" smtClean="0"/>
-              <a:t>Topic </a:t>
-            </a:r>
-            <a:r>
-              <a:rPr lang="fr-FR" b="1" dirty="0" err="1" smtClean="0"/>
-              <a:t>modeling</a:t>
-            </a:r>
-            <a:r>
-              <a:rPr lang="fr-FR" b="1" dirty="0" smtClean="0"/>
-              <a:t> :</a:t>
-            </a:r>
-          </a:p>
-          <a:p>
-            <a:pPr>
-              <a:buFont typeface="Wingdings" panose="05000000000000000000" pitchFamily="2" charset="2"/>
-              <a:buChar char="§"/>
-            </a:pPr>
-            <a:r>
-              <a:rPr lang="fr-FR" dirty="0"/>
-              <a:t> </a:t>
-            </a:r>
-            <a:r>
-              <a:rPr lang="fr-FR" dirty="0" err="1" smtClean="0"/>
-              <a:t>gensim</a:t>
-            </a:r>
-            <a:r>
-              <a:rPr lang="fr-FR" dirty="0" smtClean="0"/>
-              <a:t> : LSA, LDA, HDP</a:t>
-            </a:r>
-          </a:p>
-          <a:p>
-            <a:endParaRPr lang="fr-FR" dirty="0"/>
-          </a:p>
-          <a:p>
-            <a:r>
-              <a:rPr lang="fr-FR" b="1" dirty="0" err="1" smtClean="0"/>
-              <a:t>Preprocessing</a:t>
-            </a:r>
-            <a:r>
-              <a:rPr lang="fr-FR" b="1" dirty="0" smtClean="0"/>
-              <a:t>, traitement bas niveau :</a:t>
-            </a:r>
-          </a:p>
-          <a:p>
-            <a:pPr lvl="1"/>
-            <a:r>
-              <a:rPr lang="fr-FR" dirty="0" err="1"/>
-              <a:t>n</a:t>
-            </a:r>
-            <a:r>
-              <a:rPr lang="fr-FR" dirty="0" err="1" smtClean="0"/>
-              <a:t>ltk</a:t>
-            </a:r>
-            <a:endParaRPr lang="fr-FR" dirty="0" smtClean="0"/>
-          </a:p>
-          <a:p>
-            <a:pPr lvl="1"/>
-            <a:r>
-              <a:rPr lang="fr-FR" dirty="0" err="1" smtClean="0"/>
-              <a:t>gensim</a:t>
+              <a:t>. traitement des demandes, résumé de </a:t>
+            </a:r>
+            <a:r>
+              <a:rPr lang="fr-FR" smtClean="0"/>
+              <a:t>texte…).</a:t>
             </a:r>
             <a:endParaRPr lang="fr-FR" dirty="0" smtClean="0"/>
           </a:p>
@@ -21239,7 +21502,7 @@
     </p:spTree>
     <p:extLst>
       <p:ext uri="{BB962C8B-B14F-4D97-AF65-F5344CB8AC3E}">
-        <p14:creationId xmlns:p14="http://schemas.microsoft.com/office/powerpoint/2010/main" val="2623749037"/>
+        <p14:creationId xmlns:p14="http://schemas.microsoft.com/office/powerpoint/2010/main" val="2087992773"/>
       </p:ext>
     </p:extLst>
   </p:cSld>
@@ -21879,6 +22142,303 @@
       <p:bldP spid="20" grpId="0" animBg="1"/>
       <p:bldP spid="21" grpId="0" animBg="1"/>
     </p:bldLst>
+  </p:timing>
+</p:sld>
+</file>
+
+<file path=ppt/slides/slide40.xml><?xml version="1.0" encoding="utf-8"?>
+<p:sld xmlns:a="http://schemas.openxmlformats.org/drawingml/2006/main" xmlns:r="http://schemas.openxmlformats.org/officeDocument/2006/relationships" xmlns:p="http://schemas.openxmlformats.org/presentationml/2006/main">
+  <p:cSld>
+    <p:spTree>
+      <p:nvGrpSpPr>
+        <p:cNvPr id="1" name=""/>
+        <p:cNvGrpSpPr/>
+        <p:nvPr/>
+      </p:nvGrpSpPr>
+      <p:grpSpPr>
+        <a:xfrm>
+          <a:off x="0" y="0"/>
+          <a:ext cx="0" cy="0"/>
+          <a:chOff x="0" y="0"/>
+          <a:chExt cx="0" cy="0"/>
+        </a:xfrm>
+      </p:grpSpPr>
+      <p:sp>
+        <p:nvSpPr>
+          <p:cNvPr id="2" name="Titre 1"/>
+          <p:cNvSpPr>
+            <a:spLocks noGrp="1"/>
+          </p:cNvSpPr>
+          <p:nvPr>
+            <p:ph type="ctrTitle"/>
+          </p:nvPr>
+        </p:nvSpPr>
+        <p:spPr/>
+        <p:txBody>
+          <a:bodyPr/>
+          <a:lstStyle/>
+          <a:p>
+            <a:r>
+              <a:rPr lang="fr-FR" dirty="0" smtClean="0"/>
+              <a:t>Quelques ressources</a:t>
+            </a:r>
+            <a:endParaRPr lang="fr-FR" dirty="0"/>
+          </a:p>
+        </p:txBody>
+      </p:sp>
+      <p:sp>
+        <p:nvSpPr>
+          <p:cNvPr id="3" name="Sous-titre 2"/>
+          <p:cNvSpPr>
+            <a:spLocks noGrp="1"/>
+          </p:cNvSpPr>
+          <p:nvPr>
+            <p:ph type="subTitle" idx="1"/>
+          </p:nvPr>
+        </p:nvSpPr>
+        <p:spPr/>
+        <p:txBody>
+          <a:bodyPr/>
+          <a:lstStyle/>
+          <a:p>
+            <a:endParaRPr lang="fr-FR"/>
+          </a:p>
+        </p:txBody>
+      </p:sp>
+    </p:spTree>
+    <p:extLst>
+      <p:ext uri="{BB962C8B-B14F-4D97-AF65-F5344CB8AC3E}">
+        <p14:creationId xmlns:p14="http://schemas.microsoft.com/office/powerpoint/2010/main" val="1929882029"/>
+      </p:ext>
+    </p:extLst>
+  </p:cSld>
+  <p:clrMapOvr>
+    <a:masterClrMapping/>
+  </p:clrMapOvr>
+  <p:timing>
+    <p:tnLst>
+      <p:par>
+        <p:cTn id="1" dur="indefinite" restart="never" nodeType="tmRoot"/>
+      </p:par>
+    </p:tnLst>
+  </p:timing>
+</p:sld>
+</file>
+
+<file path=ppt/slides/slide41.xml><?xml version="1.0" encoding="utf-8"?>
+<p:sld xmlns:a="http://schemas.openxmlformats.org/drawingml/2006/main" xmlns:r="http://schemas.openxmlformats.org/officeDocument/2006/relationships" xmlns:p="http://schemas.openxmlformats.org/presentationml/2006/main">
+  <p:cSld>
+    <p:spTree>
+      <p:nvGrpSpPr>
+        <p:cNvPr id="1" name=""/>
+        <p:cNvGrpSpPr/>
+        <p:nvPr/>
+      </p:nvGrpSpPr>
+      <p:grpSpPr>
+        <a:xfrm>
+          <a:off x="0" y="0"/>
+          <a:ext cx="0" cy="0"/>
+          <a:chOff x="0" y="0"/>
+          <a:chExt cx="0" cy="0"/>
+        </a:xfrm>
+      </p:grpSpPr>
+      <p:sp>
+        <p:nvSpPr>
+          <p:cNvPr id="2" name="Titre 1"/>
+          <p:cNvSpPr>
+            <a:spLocks noGrp="1"/>
+          </p:cNvSpPr>
+          <p:nvPr>
+            <p:ph type="title"/>
+          </p:nvPr>
+        </p:nvSpPr>
+        <p:spPr/>
+        <p:txBody>
+          <a:bodyPr/>
+          <a:lstStyle/>
+          <a:p>
+            <a:r>
+              <a:rPr lang="fr-FR" dirty="0" smtClean="0"/>
+              <a:t>Ressources open source pour le NLP</a:t>
+            </a:r>
+            <a:endParaRPr lang="fr-FR" dirty="0"/>
+          </a:p>
+        </p:txBody>
+      </p:sp>
+      <p:sp>
+        <p:nvSpPr>
+          <p:cNvPr id="3" name="Espace réservé du contenu 2"/>
+          <p:cNvSpPr>
+            <a:spLocks noGrp="1"/>
+          </p:cNvSpPr>
+          <p:nvPr>
+            <p:ph idx="1"/>
+          </p:nvPr>
+        </p:nvSpPr>
+        <p:spPr/>
+        <p:txBody>
+          <a:bodyPr/>
+          <a:lstStyle/>
+          <a:p>
+            <a:pPr marL="0" indent="0">
+              <a:buNone/>
+            </a:pPr>
+            <a:r>
+              <a:rPr lang="fr-FR" b="1" dirty="0" smtClean="0"/>
+              <a:t>NLC / NER :</a:t>
+            </a:r>
+          </a:p>
+          <a:p>
+            <a:pPr>
+              <a:buFont typeface="Wingdings" panose="05000000000000000000" pitchFamily="2" charset="2"/>
+              <a:buChar char="§"/>
+            </a:pPr>
+            <a:r>
+              <a:rPr lang="fr-FR" dirty="0"/>
+              <a:t> </a:t>
+            </a:r>
+            <a:r>
+              <a:rPr lang="fr-FR" dirty="0" err="1" smtClean="0"/>
+              <a:t>spacy</a:t>
+            </a:r>
+            <a:r>
+              <a:rPr lang="fr-FR" dirty="0" smtClean="0"/>
+              <a:t> : </a:t>
+            </a:r>
+            <a:r>
+              <a:rPr lang="fr-FR" dirty="0" err="1" smtClean="0"/>
+              <a:t>industrial</a:t>
+            </a:r>
+            <a:r>
+              <a:rPr lang="fr-FR" dirty="0" smtClean="0"/>
+              <a:t> </a:t>
+            </a:r>
+            <a:r>
+              <a:rPr lang="fr-FR" dirty="0" err="1" smtClean="0"/>
+              <a:t>strength</a:t>
+            </a:r>
+            <a:r>
+              <a:rPr lang="fr-FR" dirty="0" smtClean="0"/>
+              <a:t> </a:t>
+            </a:r>
+            <a:r>
+              <a:rPr lang="fr-FR" dirty="0" err="1" smtClean="0"/>
+              <a:t>nlp</a:t>
+            </a:r>
+            <a:endParaRPr lang="fr-FR" dirty="0" smtClean="0"/>
+          </a:p>
+          <a:p>
+            <a:pPr>
+              <a:buFont typeface="Wingdings" panose="05000000000000000000" pitchFamily="2" charset="2"/>
+              <a:buChar char="§"/>
+            </a:pPr>
+            <a:r>
+              <a:rPr lang="fr-FR" dirty="0"/>
+              <a:t> </a:t>
+            </a:r>
+            <a:r>
+              <a:rPr lang="fr-FR" dirty="0" smtClean="0"/>
+              <a:t>rasa </a:t>
+            </a:r>
+            <a:r>
+              <a:rPr lang="fr-FR" dirty="0" err="1" smtClean="0"/>
+              <a:t>nlu</a:t>
+            </a:r>
+            <a:endParaRPr lang="fr-FR" dirty="0" smtClean="0"/>
+          </a:p>
+          <a:p>
+            <a:pPr>
+              <a:buFont typeface="Wingdings" panose="05000000000000000000" pitchFamily="2" charset="2"/>
+              <a:buChar char="§"/>
+            </a:pPr>
+            <a:endParaRPr lang="fr-FR" dirty="0" smtClean="0"/>
+          </a:p>
+          <a:p>
+            <a:pPr marL="0" indent="0">
+              <a:buNone/>
+            </a:pPr>
+            <a:r>
+              <a:rPr lang="fr-FR" b="1" dirty="0" smtClean="0"/>
+              <a:t>Topic </a:t>
+            </a:r>
+            <a:r>
+              <a:rPr lang="fr-FR" b="1" dirty="0" err="1" smtClean="0"/>
+              <a:t>modeling</a:t>
+            </a:r>
+            <a:r>
+              <a:rPr lang="fr-FR" b="1" dirty="0" smtClean="0"/>
+              <a:t> :</a:t>
+            </a:r>
+          </a:p>
+          <a:p>
+            <a:pPr>
+              <a:buFont typeface="Wingdings" panose="05000000000000000000" pitchFamily="2" charset="2"/>
+              <a:buChar char="§"/>
+            </a:pPr>
+            <a:r>
+              <a:rPr lang="fr-FR" dirty="0"/>
+              <a:t> </a:t>
+            </a:r>
+            <a:r>
+              <a:rPr lang="fr-FR" dirty="0" err="1" smtClean="0"/>
+              <a:t>gensim</a:t>
+            </a:r>
+            <a:r>
+              <a:rPr lang="fr-FR" dirty="0" smtClean="0"/>
+              <a:t> : LSA, LDA, HDP</a:t>
+            </a:r>
+          </a:p>
+          <a:p>
+            <a:endParaRPr lang="fr-FR" dirty="0"/>
+          </a:p>
+          <a:p>
+            <a:r>
+              <a:rPr lang="fr-FR" b="1" dirty="0" err="1" smtClean="0"/>
+              <a:t>Preprocessing</a:t>
+            </a:r>
+            <a:r>
+              <a:rPr lang="fr-FR" b="1" dirty="0" smtClean="0"/>
+              <a:t>, traitement bas niveau :</a:t>
+            </a:r>
+          </a:p>
+          <a:p>
+            <a:pPr lvl="1"/>
+            <a:r>
+              <a:rPr lang="fr-FR" dirty="0" err="1"/>
+              <a:t>n</a:t>
+            </a:r>
+            <a:r>
+              <a:rPr lang="fr-FR" dirty="0" err="1" smtClean="0"/>
+              <a:t>ltk</a:t>
+            </a:r>
+            <a:endParaRPr lang="fr-FR" dirty="0" smtClean="0"/>
+          </a:p>
+          <a:p>
+            <a:pPr lvl="1"/>
+            <a:r>
+              <a:rPr lang="fr-FR" dirty="0" err="1" smtClean="0"/>
+              <a:t>gensim</a:t>
+            </a:r>
+            <a:endParaRPr lang="fr-FR" dirty="0" smtClean="0"/>
+          </a:p>
+        </p:txBody>
+      </p:sp>
+    </p:spTree>
+    <p:extLst>
+      <p:ext uri="{BB962C8B-B14F-4D97-AF65-F5344CB8AC3E}">
+        <p14:creationId xmlns:p14="http://schemas.microsoft.com/office/powerpoint/2010/main" val="2623749037"/>
+      </p:ext>
+    </p:extLst>
+  </p:cSld>
+  <p:clrMapOvr>
+    <a:masterClrMapping/>
+  </p:clrMapOvr>
+  <p:timing>
+    <p:tnLst>
+      <p:par>
+        <p:cTn id="1" dur="indefinite" restart="never" nodeType="tmRoot"/>
+      </p:par>
+    </p:tnLst>
   </p:timing>
 </p:sld>
 </file>

</xml_diff>